<commit_message>
Unificar integrantes Daniela Peña y Mirko Flores en documentación
</commit_message>
<xml_diff>
--- a/docs/presentacion.pptx
+++ b/docs/presentacion.pptx
@@ -338,7 +338,7 @@
           <a:lstStyle/>
           <a:p>
             <a:r>
-              <a:t>Duración: 40 segundos. Presentación de Daniela Peña. Introducir el caso contextualizado y el objetivo. La pauta asigna 10 minutos de exposición y 10 de preguntas. Confirmar modalidad individual con el docente.</a:t>
+              <a:t xml:space="preserve">Duración: 40 segundos. Presentación de Daniela Peña y Mirko Flores. Introducir el caso contextualizado y el objetivo. La pauta asigna 10 minutos de exposición y 10 de preguntas. Distribuir la exposición entre ambos integrantes.</a:t>
             </a:r>
           </a:p>
         </p:txBody>
@@ -877,7 +877,7 @@
           <a:lstStyle/>
           <a:p>
             <a:r>
-              <a:t>Duración: 80 segundos. Daniela debe preparar sus justificaciones y conclusiones personales a partir de la ejecución. Explicar el riesgo de una cita válida con afirmación incorrecta, la falta de permisos documentales y el sesgo del conjunto pequeño. Cerrar dentro de los 10 minutos y abrir preguntas durante 10 minutos.</a:t>
+              <a:t xml:space="preserve">Duración: 80 segundos. Daniela Peña y Mirko Flores deben preparar sus justificaciones y conclusiones personales a partir de la ejecución. Explicar el riesgo de una cita válida con afirmación incorrecta, la falta de permisos documentales y el sesgo del conjunto pequeño. Cerrar dentro de los 10 minutos y abrir preguntas durante 10 minutos.</a:t>
             </a:r>
           </a:p>
         </p:txBody>
@@ -1490,7 +1490,7 @@
                 <a:ea typeface="Arial"/>
                 <a:cs typeface="Arial"/>
               </a:rPr>
-              <a:t>Daniela Peña</a:t>
+              <a:t xml:space="preserve">Daniela Peña y Mirko Flores</a:t>
             </a:r>
             <a:r>
               <a:rPr lang="es-CL" sz="2100" b="0" dirty="0">
@@ -1501,7 +1501,7 @@
                 <a:ea typeface="Arial"/>
                 <a:cs typeface="Arial"/>
               </a:rPr>
-              <a:t> – Mirko Flores</a:t>
+              <a:t xml:space="preserve"/>
             </a:r>
             <a:endParaRPr sz="2100" b="0" dirty="0">
               <a:solidFill>

</xml_diff>